<commit_message>
Added eligibility list, improved presentation
</commit_message>
<xml_diff>
--- a/wbso/docs/WBSO_handover.pptx
+++ b/wbso/docs/WBSO_handover.pptx
@@ -118,38 +118,38 @@
   <p:extLst>
     <p:ext uri="{521415D9-36F7-43E2-AB2F-B90AF26B5E84}">
       <p14:sectionLst xmlns:p14="http://schemas.microsoft.com/office/powerpoint/2010/main">
-        <p14:section name="Welcome" id="{0A06FAB9-B52A-9982-A19E-2AB9A5B2B04E}">
+        <p14:section name="Welcome" id="{B3D35C4E-9507-4FD3-2283-FB43315DBC72}">
           <p14:sldIdLst>
             <p14:sldId id="256"/>
             <p14:sldId id="257"/>
           </p14:sldIdLst>
         </p14:section>
-        <p14:section name="WBSO" id="{D9C8F2CB-A0F9-7BA3-CFA2-BAF335316C2D}">
+        <p14:section name="WBSO" id="{964E17BC-1464-640D-1AAA-59A96DD382F7}">
           <p14:sldIdLst>
             <p14:sldId id="258"/>
             <p14:sldId id="259"/>
           </p14:sldIdLst>
         </p14:section>
-        <p14:section name="Validaide and WBSO" id="{F403BFD2-B6D7-BD9F-B834-74348ECBFF73}">
+        <p14:section name="Validaide and WBSO" id="{139BB475-A115-22A0-96DC-92160FE28EDD}">
           <p14:sldIdLst>
             <p14:sldId id="260"/>
             <p14:sldId id="261"/>
           </p14:sldIdLst>
         </p14:section>
-        <p14:section name="Reporting" id="{A6EAAF89-6CFA-0A39-9595-5B4899ADB382}">
+        <p14:section name="Reporting" id="{0CF521DC-B0D3-F636-CD4D-8E630E9D58ED}">
           <p14:sldIdLst>
             <p14:sldId id="262"/>
             <p14:sldId id="263"/>
             <p14:sldId id="264"/>
           </p14:sldIdLst>
         </p14:section>
-        <p14:section name="Results and handover" id="{1429C2B3-D0A7-3525-66FA-D9AE6DABF836}">
+        <p14:section name="Results and what's next" id="{1407C635-4132-696B-411C-54B7264EF898}">
           <p14:sldIdLst>
             <p14:sldId id="265"/>
             <p14:sldId id="266"/>
           </p14:sldIdLst>
         </p14:section>
-        <p14:section name="Close" id="{8B7BD2EB-2B47-0427-0972-603A96AF7BCD}">
+        <p14:section name="Close" id="{4822D52D-25EE-C736-B553-A7AEAE6D13B7}">
           <p14:sldIdLst>
             <p14:sldId id="267"/>
           </p14:sldIdLst>
@@ -277,38 +277,38 @@
                 <c:formatCode>General</c:formatCode>
                 <c:ptCount val="9"/>
                 <c:pt idx="0">
-                  <c:v>9</c:v>
+                  <c:v>4.5999999999999996</c:v>
                 </c:pt>
                 <c:pt idx="1">
-                  <c:v>229.6</c:v>
+                  <c:v>202.1</c:v>
                 </c:pt>
                 <c:pt idx="2">
-                  <c:v>125.2</c:v>
+                  <c:v>130.1</c:v>
                 </c:pt>
                 <c:pt idx="3">
-                  <c:v>113.2</c:v>
+                  <c:v>112</c:v>
                 </c:pt>
                 <c:pt idx="4">
-                  <c:v>253.2</c:v>
+                  <c:v>205.6</c:v>
                 </c:pt>
                 <c:pt idx="5">
-                  <c:v>255</c:v>
+                  <c:v>244.1</c:v>
                 </c:pt>
                 <c:pt idx="6">
-                  <c:v>14.4</c:v>
+                  <c:v>17</c:v>
                 </c:pt>
                 <c:pt idx="7">
-                  <c:v>187.4</c:v>
+                  <c:v>144.19999999999999</c:v>
                 </c:pt>
                 <c:pt idx="8">
-                  <c:v>29.6</c:v>
+                  <c:v>29</c:v>
                 </c:pt>
               </c:numCache>
             </c:numRef>
           </c:val>
           <c:extLst>
             <c:ext xmlns:c16="http://schemas.microsoft.com/office/drawing/2014/chart" uri="{C3380CC4-5D6E-409C-BE32-E72D297353CC}">
-              <c16:uniqueId val="{00000000-A216-AB45-8005-5662CABCB1B4}"/>
+              <c16:uniqueId val="{00000000-C806-F644-9300-8E235C6FBF82}"/>
             </c:ext>
           </c:extLst>
         </c:ser>
@@ -514,9 +514,9 @@
           </c:dLbls>
           <c:cat>
             <c:strRef>
-              <c:f>Sheet1!$A$2:$A$13</c:f>
+              <c:f>Sheet1!$A$2:$A$10</c:f>
               <c:strCache>
-                <c:ptCount val="12"/>
+                <c:ptCount val="9"/>
                 <c:pt idx="0">
                   <c:v>Csenge Varjas</c:v>
                 </c:pt>
@@ -524,33 +524,24 @@
                   <c:v>Murat Koylu</c:v>
                 </c:pt>
                 <c:pt idx="2">
-                  <c:v>Andrei Costantea</c:v>
+                  <c:v>Serena Toto</c:v>
                 </c:pt>
                 <c:pt idx="3">
-                  <c:v>Yakup Arslan</c:v>
+                  <c:v>Jure Bernava Prah</c:v>
                 </c:pt>
                 <c:pt idx="4">
-                  <c:v>Serena Toto</c:v>
+                  <c:v>Ana Samoukova</c:v>
                 </c:pt>
                 <c:pt idx="5">
-                  <c:v>Jure Bernava Prah</c:v>
+                  <c:v>Utku Yazgan</c:v>
                 </c:pt>
                 <c:pt idx="6">
-                  <c:v>Ana Samoukova</c:v>
+                  <c:v>Daumantas Patapas</c:v>
                 </c:pt>
                 <c:pt idx="7">
-                  <c:v>Utku Yazgan</c:v>
+                  <c:v>Ayush Singhal</c:v>
                 </c:pt>
                 <c:pt idx="8">
-                  <c:v>(unassigned)</c:v>
-                </c:pt>
-                <c:pt idx="9">
-                  <c:v>Daumantas Patapas</c:v>
-                </c:pt>
-                <c:pt idx="10">
-                  <c:v>Ayush Singhal</c:v>
-                </c:pt>
-                <c:pt idx="11">
                   <c:v>Anca Negulescu</c:v>
                 </c:pt>
               </c:strCache>
@@ -558,52 +549,43 @@
           </c:cat>
           <c:val>
             <c:numRef>
-              <c:f>Sheet1!$B$2:$B$13</c:f>
+              <c:f>Sheet1!$B$2:$B$10</c:f>
               <c:numCache>
                 <c:formatCode>General</c:formatCode>
-                <c:ptCount val="12"/>
+                <c:ptCount val="9"/>
                 <c:pt idx="0">
                   <c:v>1.7</c:v>
                 </c:pt>
                 <c:pt idx="1">
-                  <c:v>2.5</c:v>
+                  <c:v>2.8</c:v>
                 </c:pt>
                 <c:pt idx="2">
-                  <c:v>7.3</c:v>
+                  <c:v>23.3</c:v>
                 </c:pt>
                 <c:pt idx="3">
-                  <c:v>17.600000000000001</c:v>
+                  <c:v>43.9</c:v>
                 </c:pt>
                 <c:pt idx="4">
-                  <c:v>27.7</c:v>
+                  <c:v>58.6</c:v>
                 </c:pt>
                 <c:pt idx="5">
-                  <c:v>40.4</c:v>
+                  <c:v>86.9</c:v>
                 </c:pt>
                 <c:pt idx="6">
-                  <c:v>69.2</c:v>
+                  <c:v>181.8</c:v>
                 </c:pt>
                 <c:pt idx="7">
-                  <c:v>73.3</c:v>
+                  <c:v>191.4</c:v>
                 </c:pt>
                 <c:pt idx="8">
-                  <c:v>96</c:v>
-                </c:pt>
-                <c:pt idx="9">
-                  <c:v>184.4</c:v>
-                </c:pt>
-                <c:pt idx="10">
-                  <c:v>191</c:v>
-                </c:pt>
-                <c:pt idx="11">
-                  <c:v>505.7</c:v>
+                  <c:v>498.5</c:v>
                 </c:pt>
               </c:numCache>
             </c:numRef>
           </c:val>
           <c:extLst>
             <c:ext xmlns:c16="http://schemas.microsoft.com/office/drawing/2014/chart" uri="{C3380CC4-5D6E-409C-BE32-E72D297353CC}">
-              <c16:uniqueId val="{00000000-66D3-4241-83CB-C9F436D47B2F}"/>
+              <c16:uniqueId val="{00000000-41BC-7F4E-96CC-E4A706BA21E0}"/>
             </c:ext>
           </c:extLst>
         </c:ser>
@@ -663,7 +645,7 @@
         <c:axId val="2094734552"/>
         <c:scaling>
           <c:orientation val="minMax"/>
-          <c:max val="620"/>
+          <c:max val="600"/>
           <c:min val="0"/>
         </c:scaling>
         <c:delete val="1"/>
@@ -726,7 +708,7 @@
     </p:spTree>
     <p:extLst>
       <p:ext uri="{BB962C8B-B14F-4D97-AF65-F5344CB8AC3E}">
-        <p14:creationId xmlns:p14="http://schemas.microsoft.com/office/powerpoint/2010/main" val="2229094334"/>
+        <p14:creationId xmlns:p14="http://schemas.microsoft.com/office/powerpoint/2010/main" val="1964019863"/>
       </p:ext>
     </p:extLst>
   </p:cSld>
@@ -959,7 +941,7 @@
           <a:p>
             <a:r>
               <a:rPr lang="en-US" dirty="0"/>
-              <a:t>Numbers come from the nine workbooks in wbso/reports, generated on 13 October 2026. 1,217 hours in nine months, 41 percent of the grant. The monthly profile is uneven: January, July and September are close to zero, which is more likely missing labels or story points than missing work. 96 hours sit on tickets with no assignee. The per-person list includes everyone who touched a labelled ticket, including colleagues who are not on Validaide B.V. payroll; the payroll filter is applied afterwards. One person with zero hours is omitted from the chart.</a:t>
+              <a:t>Numbers come from the nine re-run workbooks in wbso/reports, generated on 13 October 2026 with the working-day method and the eligibility list of 10 names. 1,089 counted hours in nine months, 36 percent of the grant. 126 hours are not counted: 102 on unassigned tickets and 24 by two colleagues not on the list. January, July and September are close to zero, which is more likely missing labels or story points than missing work. Nine of the ten people on the list have hours. The February, March and June workbooks flag many days above 8 hours per person: large tickets held briefly. Review those before filing.</a:t>
             </a:r>
           </a:p>
         </p:txBody>
@@ -1133,7 +1115,7 @@
           <a:p>
             <a:r>
               <a:rPr lang="en-US" dirty="0"/>
-              <a:t>Close with the pointers: everything is in the reporting-utils repository, the RVO letters are in docs/, and SubVice remains the contact towards RVO. Open the floor for questions.</a:t>
+              <a:t>Close with the pointers: everything is in the reporting-utils repository, the RVO letters are in wbso/docs/, and SubVice remains the contact towards RVO. Open the floor for questions.</a:t>
             </a:r>
           </a:p>
         </p:txBody>
@@ -1655,7 +1637,7 @@
           <a:p>
             <a:r>
               <a:rPr lang="en-US" dirty="0"/>
-              <a:t>This is the honest picture of 2025. The old process depended on nine people filling in personal spreadsheets, and the hours that could be substantiated at the end were 758 of 7,000. RVO corrected the benefit by 89,888 euro and the decision letter notes that the data can still be checked later. Whether the real R&amp;D effort was higher is beside the point: what we could not evidence, we could not claim. That is the problem the new approach fixes.</a:t>
+              <a:t>This is the honest picture of 2025. The gap between 7,000 granted and 758 reported hours was mostly real: 2025 was the year Validaide merged into SkyCell, the team shrank, many colleagues left, and the people who stayed prioritised customer needs and the tech migration over the R&amp;D projects. The 7,000 hours had been planned for a team that no longer existed. On top of that, the manual process made even the remaining R&amp;D hard to evidence: nine personal spreadsheets, filled from memory. RVO corrected the benefit by 89,888 euro and the letter notes the data can still be checked later. Two lessons for 2026: apply for hours the actual team can deliver, and substantiate what is delivered with evidence, which is what the new approach does.</a:t>
             </a:r>
           </a:p>
         </p:txBody>
@@ -1829,7 +1811,7 @@
           <a:p>
             <a:r>
               <a:rPr lang="en-US" dirty="0"/>
-              <a:t>Demo this live if there is time: compile once, set the two variables, run for the month. The README in wbso/ has the same instructions. The right-hand column is the review you do before trusting a number: statuses classified, no skipped issues, and the payroll filter applied by hand because the tool deliberately includes every assignee.</a:t>
+              <a:t>Demo this live if there is time: compile once, set the two variables, run for the month. The README in wbso/ has the same instructions. The right-hand column is the review you do before trusting a number: statuses classified, no skipped issues, and the eligibility list kept current, because the tool counts only the names in it and shows everyone else separately.</a:t>
             </a:r>
           </a:p>
         </p:txBody>
@@ -2101,7 +2083,7 @@
           </a:prstGeom>
           <a:extLst>
             <a:ext uri="{C572A759-6A51-4108-AA02-DFA0A04FC94B}">
-              <ma14:wrappingTextBoxFlag xmlns:ma14="http://schemas.microsoft.com/office/mac/drawingml/2011/main" xmlns="" val="0"/>
+              <ma14:wrappingTextBoxFlag xmlns="" xmlns:ma14="http://schemas.microsoft.com/office/mac/drawingml/2011/main" val="0"/>
             </a:ext>
           </a:extLst>
         </p:spPr>
@@ -2307,7 +2289,7 @@
           </a:prstGeom>
           <a:extLst>
             <a:ext uri="{C572A759-6A51-4108-AA02-DFA0A04FC94B}">
-              <ma14:wrappingTextBoxFlag xmlns:ma14="http://schemas.microsoft.com/office/mac/drawingml/2011/main" xmlns="" val="0"/>
+              <ma14:wrappingTextBoxFlag xmlns="" xmlns:ma14="http://schemas.microsoft.com/office/mac/drawingml/2011/main" val="0"/>
             </a:ext>
           </a:extLst>
         </p:spPr>
@@ -2337,7 +2319,7 @@
           <p:cNvPr id="3" name="TextBox 2">
             <a:extLst>
               <a:ext uri="{FF2B5EF4-FFF2-40B4-BE49-F238E27FC236}">
-                <a16:creationId xmlns:a16="http://schemas.microsoft.com/office/drawing/2014/main" id="{201E37A1-6DCD-791C-CC0A-EAFE77BA6CBA}"/>
+                <a16:creationId xmlns:a16="http://schemas.microsoft.com/office/drawing/2014/main" id="{352CA44E-71C6-A23F-C66D-E512F13B6063}"/>
               </a:ext>
             </a:extLst>
           </p:cNvPr>
@@ -2982,7 +2964,7 @@
                   <a:schemeClr val="accent1"/>
                 </a:solidFill>
               </a:rPr>
-              <a:t>1,217 h</a:t>
+              <a:t>1,089 h</a:t>
             </a:r>
             <a:endParaRPr lang="en-US" sz="3000" dirty="0"/>
           </a:p>
@@ -3018,7 +3000,7 @@
                   <a:schemeClr val="accent6"/>
                 </a:solidFill>
               </a:rPr>
-              <a:t>substantiated in nine monthly runs</a:t>
+              <a:t>counted for eligible staff, January to September</a:t>
             </a:r>
             <a:endParaRPr lang="en-US" sz="1100" dirty="0"/>
           </a:p>
@@ -3088,7 +3070,7 @@
                   <a:schemeClr val="accent1"/>
                 </a:solidFill>
               </a:rPr>
-              <a:t>41%</a:t>
+              <a:t>36%</a:t>
             </a:r>
             <a:endParaRPr lang="en-US" sz="3000" dirty="0"/>
           </a:p>
@@ -3194,7 +3176,7 @@
                   <a:schemeClr val="accent1"/>
                 </a:solidFill>
               </a:rPr>
-              <a:t>12</a:t>
+              <a:t>9</a:t>
             </a:r>
             <a:endParaRPr lang="en-US" sz="3000" dirty="0"/>
           </a:p>
@@ -3230,7 +3212,7 @@
                   <a:schemeClr val="accent6"/>
                 </a:solidFill>
               </a:rPr>
-              <a:t>people with hours, all assignees</a:t>
+              <a:t>of the 10 people on the eligibility list have hours</a:t>
             </a:r>
             <a:endParaRPr lang="en-US" sz="1100" dirty="0"/>
           </a:p>
@@ -3300,7 +3282,7 @@
                   <a:schemeClr val="accent5"/>
                 </a:solidFill>
               </a:rPr>
-              <a:t>96 h</a:t>
+              <a:t>126 h</a:t>
             </a:r>
             <a:endParaRPr lang="en-US" sz="3000" dirty="0"/>
           </a:p>
@@ -3336,7 +3318,7 @@
                   <a:schemeClr val="accent6"/>
                 </a:solidFill>
               </a:rPr>
-              <a:t>on unassigned tickets</a:t>
+              <a:t>not counted: 102 h unassigned, 24 h non-eligible</a:t>
             </a:r>
             <a:endParaRPr lang="en-US" sz="1100" dirty="0"/>
           </a:p>
@@ -3372,7 +3354,7 @@
                   <a:schemeClr val="tx2"/>
                 </a:solidFill>
               </a:rPr>
-              <a:t>Hours per month</a:t>
+              <a:t>Hours per month, eligible staff</a:t>
             </a:r>
             <a:endParaRPr lang="en-US" sz="1300" dirty="0"/>
           </a:p>
@@ -3424,7 +3406,7 @@
                   <a:schemeClr val="tx2"/>
                 </a:solidFill>
               </a:rPr>
-              <a:t>Hours per person, year to date</a:t>
+              <a:t>Hours per person, eligible staff, year to date</a:t>
             </a:r>
             <a:endParaRPr lang="en-US" sz="1300" dirty="0"/>
           </a:p>
@@ -3466,7 +3448,7 @@
           </a:prstGeom>
           <a:extLst>
             <a:ext uri="{C572A759-6A51-4108-AA02-DFA0A04FC94B}">
-              <ma14:wrappingTextBoxFlag xmlns:ma14="http://schemas.microsoft.com/office/mac/drawingml/2011/main" xmlns="" val="0"/>
+              <ma14:wrappingTextBoxFlag xmlns="" xmlns:ma14="http://schemas.microsoft.com/office/mac/drawingml/2011/main" val="0"/>
             </a:ext>
           </a:extLst>
         </p:spPr>
@@ -3681,7 +3663,7 @@
                   <a:schemeClr val="tx1"/>
                 </a:solidFill>
               </a:rPr>
-              <a:t>Pace is about 135 h a month, so roughly 1,600 h by December: half the grant. At €17 per hour that is a correction of about €23,000 unless more qualifying work gets labelled.</a:t>
+              <a:t>Counted pace is about 120 h a month, so roughly 1,450 h by December: under half the grant. At €17 per hour that is a correction of about €25,000 unless more qualifying work gets labelled.</a:t>
             </a:r>
             <a:endParaRPr lang="en-US" sz="1150" dirty="0"/>
           </a:p>
@@ -3776,7 +3758,7 @@
                   <a:schemeClr val="tx1"/>
                 </a:solidFill>
               </a:rPr>
-              <a:t>Only Validaide B.V. payroll staff count. The tool includes every assignee; filter the Summary before anything goes to SubVice (the application forecast 4 S&amp;O employees).</a:t>
+              <a:t>Only Validaide B.V. payroll staff count. Keep wbso/eligible.txt current; the tool lists everyone else separately. Remote colleagues on a non-Dutch payroll do not count; ask SubVice about cross-border cases.</a:t>
             </a:r>
             <a:endParaRPr lang="en-US" sz="1150" dirty="0"/>
           </a:p>
@@ -4472,7 +4454,7 @@
                   <a:schemeClr val="tx1"/>
                 </a:solidFill>
               </a:rPr>
-              <a:t>Re-run all of 2026, apply the payroll filter, send totals and BSNs to SubVice.</a:t>
+              <a:t>Re-run all of 2026 with the eligibility list; send Summary, Daily and BSNs to SubVice.</a:t>
             </a:r>
             <a:endParaRPr lang="en-US" sz="1050" dirty="0"/>
           </a:p>
@@ -4716,7 +4698,7 @@
           </a:prstGeom>
           <a:extLst>
             <a:ext uri="{C572A759-6A51-4108-AA02-DFA0A04FC94B}">
-              <ma14:wrappingTextBoxFlag xmlns:ma14="http://schemas.microsoft.com/office/mac/drawingml/2011/main" xmlns="" val="0"/>
+              <ma14:wrappingTextBoxFlag xmlns="" xmlns:ma14="http://schemas.microsoft.com/office/mac/drawingml/2011/main" val="0"/>
             </a:ext>
           </a:extLst>
         </p:spPr>
@@ -5001,7 +4983,7 @@
                   <a:schemeClr val="bg2"/>
                 </a:solidFill>
               </a:rPr>
-              <a:t>wbso/WbsoHours.java and README.md (the tool), wbso/reports/ (monthly workbooks), docs/ (RVO letters 2025 and 2026, old timesheet).</a:t>
+              <a:t>wbso/WbsoHours.java and README.md (the tool), wbso/eligible.txt (who counts), wbso/reports/ (monthly workbooks), wbso/docs/ (RVO letters 2025 and 2026, old timesheet).</a:t>
             </a:r>
             <a:endParaRPr lang="en-US" sz="1200" dirty="0"/>
           </a:p>
@@ -5146,7 +5128,23 @@
                   <a:schemeClr val="tx2"/>
                 </a:solidFill>
               </a:rPr>
-              <a:t>This session is an introduction over everything related to the WBSO and what’s needed to run it: the scheme, the people, the tooling and the calendar.</a:t>
+              <a:t>This session </a:t>
+            </a:r>
+            <a:r>
+              <a:rPr lang="en-US" dirty="0">
+                <a:solidFill>
+                  <a:schemeClr val="tx2"/>
+                </a:solidFill>
+              </a:rPr>
+              <a:t>is about WBSO and what is</a:t>
+            </a:r>
+            <a:r>
+              <a:rPr lang="en-US" sz="1800" dirty="0">
+                <a:solidFill>
+                  <a:schemeClr val="tx2"/>
+                </a:solidFill>
+              </a:rPr>
+              <a:t> needed to run it: the scheme, the people, the tooling and the calendar.</a:t>
             </a:r>
             <a:endParaRPr lang="en-US" sz="1800" dirty="0"/>
           </a:p>
@@ -5365,18 +5363,13 @@
               <a:buNone/>
             </a:pPr>
             <a:r>
-              <a:rPr lang="en-US" sz="1400" dirty="0"/>
-              <a:t>k</a:t>
-            </a:r>
-            <a:r>
               <a:rPr lang="en-US" sz="1400" dirty="0">
                 <a:solidFill>
                   <a:schemeClr val="tx1"/>
                 </a:solidFill>
               </a:rPr>
-              <a:t>now the monthly hours reports</a:t>
-            </a:r>
-            <a:endParaRPr lang="en-US" sz="1400" dirty="0"/>
+              <a:t>be able to run the monthly hours report</a:t>
+            </a:r>
           </a:p>
         </p:txBody>
       </p:sp>
@@ -6082,7 +6075,7 @@
           </a:prstGeom>
           <a:extLst>
             <a:ext uri="{C572A759-6A51-4108-AA02-DFA0A04FC94B}">
-              <ma14:wrappingTextBoxFlag xmlns:ma14="http://schemas.microsoft.com/office/mac/drawingml/2011/main" xmlns="" val="0"/>
+              <ma14:wrappingTextBoxFlag xmlns="" xmlns:ma14="http://schemas.microsoft.com/office/mac/drawingml/2011/main" val="0"/>
             </a:ext>
           </a:extLst>
         </p:spPr>
@@ -6818,7 +6811,7 @@
           </a:prstGeom>
           <a:extLst>
             <a:ext uri="{C572A759-6A51-4108-AA02-DFA0A04FC94B}">
-              <ma14:wrappingTextBoxFlag xmlns:ma14="http://schemas.microsoft.com/office/mac/drawingml/2011/main" xmlns="" val="0"/>
+              <ma14:wrappingTextBoxFlag xmlns="" xmlns:ma14="http://schemas.microsoft.com/office/mac/drawingml/2011/main" val="0"/>
             </a:ext>
           </a:extLst>
         </p:spPr>
@@ -8527,7 +8520,7 @@
           </a:prstGeom>
           <a:extLst>
             <a:ext uri="{C572A759-6A51-4108-AA02-DFA0A04FC94B}">
-              <ma14:wrappingTextBoxFlag xmlns:ma14="http://schemas.microsoft.com/office/mac/drawingml/2011/main" xmlns="" val="0"/>
+              <ma14:wrappingTextBoxFlag xmlns="" xmlns:ma14="http://schemas.microsoft.com/office/mac/drawingml/2011/main" val="0"/>
             </a:ext>
           </a:extLst>
         </p:spPr>
@@ -9660,7 +9653,7 @@
           </a:prstGeom>
           <a:extLst>
             <a:ext uri="{C572A759-6A51-4108-AA02-DFA0A04FC94B}">
-              <ma14:wrappingTextBoxFlag xmlns:ma14="http://schemas.microsoft.com/office/mac/drawingml/2011/main" xmlns="" val="0"/>
+              <ma14:wrappingTextBoxFlag xmlns="" xmlns:ma14="http://schemas.microsoft.com/office/mac/drawingml/2011/main" val="0"/>
             </a:ext>
           </a:extLst>
         </p:spPr>
@@ -11119,7 +11112,7 @@
           </a:prstGeom>
           <a:extLst>
             <a:ext uri="{C572A759-6A51-4108-AA02-DFA0A04FC94B}">
-              <ma14:wrappingTextBoxFlag xmlns:ma14="http://schemas.microsoft.com/office/mac/drawingml/2011/main" xmlns="" val="0"/>
+              <ma14:wrappingTextBoxFlag xmlns="" xmlns:ma14="http://schemas.microsoft.com/office/mac/drawingml/2011/main" val="0"/>
             </a:ext>
           </a:extLst>
         </p:spPr>
@@ -11778,7 +11771,7 @@
                   <a:schemeClr val="tx2"/>
                 </a:solidFill>
               </a:rPr>
-              <a:t>No evidence trail</a:t>
+              <a:t>Why 758 and not 7,000</a:t>
             </a:r>
             <a:endParaRPr lang="en-US" sz="1500" dirty="0"/>
           </a:p>
@@ -11817,7 +11810,7 @@
                   <a:schemeClr val="tx1"/>
                 </a:solidFill>
               </a:rPr>
-              <a:t>Nothing tied an hour to a ticket, a status change or a commit. Nine people had to remember, and most did not.</a:t>
+              <a:t>Mostly real, not a reporting failure: Validaide merged into SkyCell, the team shrank, many colleagues left, and those who stayed put customers and the tech migration before R&amp;D.</a:t>
             </a:r>
             <a:endParaRPr lang="en-US" sz="1200" dirty="0"/>
           </a:p>
@@ -12142,7 +12135,7 @@
                   <a:schemeClr val="bg2"/>
                 </a:solidFill>
               </a:rPr>
-              <a:t>RVO flagged a correction of more than 50% of the hours. Benefit kept: €12,280 of the €102,168 granted.</a:t>
+              <a:t>RVO flagged a correction of more than 50% of the hours. Benefit kept: €12,280 of the €102,168 granted. The timesheets could only evidence what was left.</a:t>
             </a:r>
             <a:endParaRPr lang="en-US" sz="1050" dirty="0"/>
           </a:p>
@@ -12168,7 +12161,7 @@
           </a:prstGeom>
           <a:extLst>
             <a:ext uri="{C572A759-6A51-4108-AA02-DFA0A04FC94B}">
-              <ma14:wrappingTextBoxFlag xmlns:ma14="http://schemas.microsoft.com/office/mac/drawingml/2011/main" xmlns="" val="0"/>
+              <ma14:wrappingTextBoxFlag xmlns="" xmlns:ma14="http://schemas.microsoft.com/office/mac/drawingml/2011/main" val="0"/>
             </a:ext>
           </a:extLst>
         </p:spPr>
@@ -13056,7 +13049,7 @@
                   <a:schemeClr val="tx1"/>
                 </a:solidFill>
               </a:rPr>
-              <a:t>Hours go to whoever held the ticket in a DEV or QA status, in proportion to time held, inside the reported month.</a:t>
+              <a:t>Hours go to whoever held the ticket in a DEV or QA status, in proportion to time held on working days, split per day inside the month.</a:t>
             </a:r>
             <a:endParaRPr lang="en-US" sz="1100" dirty="0"/>
           </a:p>
@@ -13257,7 +13250,7 @@
                   <a:schemeClr val="tx1"/>
                 </a:solidFill>
               </a:rPr>
-              <a:t>One .xlsx per month: Summary, Detail, Issues, StatusAudit and a Notes tab written for the auditor.</a:t>
+              <a:t>One .xlsx per month: Summary, Daily (person, project, day), DayTotals, Evidence, Detail, Issues, StatusAudit, Notes.</a:t>
             </a:r>
             <a:endParaRPr lang="en-US" sz="1100" dirty="0"/>
           </a:p>
@@ -13272,7 +13265,7 @@
           <p:nvPr>
             <p:extLst>
               <p:ext uri="{D42A27DB-BD31-4B8C-83A1-F6EECF244321}">
-                <p14:modId xmlns:p14="http://schemas.microsoft.com/office/powerpoint/2010/main" val="1579011935"/>
+                <p14:modId xmlns:p14="http://schemas.microsoft.com/office/powerpoint/2010/main" val="4120195555"/>
               </p:ext>
             </p:extLst>
           </p:nvPr>
@@ -13992,7 +13985,7 @@
                             <a:srgbClr val="1D1D1B"/>
                           </a:solidFill>
                         </a:rPr>
-                        <a:t>Timestamps in the changelog; every figure traces to issue, person, month and phase</a:t>
+                        <a:t>Changelog timestamps and authors; every hour traces to issue, person, project and day</a:t>
                       </a:r>
                       <a:endParaRPr lang="en-US" sz="1100" dirty="0"/>
                     </a:p>
@@ -14176,7 +14169,7 @@
                             <a:srgbClr val="1D1D1B"/>
                           </a:solidFill>
                         </a:rPr>
-                        <a:t>Months add up to each issue’s total; reproducible by anyone with Jira access</a:t>
+                        <a:t>Months add up to each issue’s total; reproducible by anyone with Jira access to VALCM</a:t>
                       </a:r>
                       <a:endParaRPr lang="en-US" sz="1100" dirty="0"/>
                     </a:p>
@@ -14250,7 +14243,7 @@
           </a:prstGeom>
           <a:extLst>
             <a:ext uri="{C572A759-6A51-4108-AA02-DFA0A04FC94B}">
-              <ma14:wrappingTextBoxFlag xmlns:ma14="http://schemas.microsoft.com/office/mac/drawingml/2011/main" xmlns="" val="0"/>
+              <ma14:wrappingTextBoxFlag xmlns="" xmlns:ma14="http://schemas.microsoft.com/office/mac/drawingml/2011/main" val="0"/>
             </a:ext>
           </a:extLst>
         </p:spPr>
@@ -14349,11 +14342,11 @@
         <p:spPr>
           <a:xfrm>
             <a:off x="548640" y="1325880"/>
-            <a:ext cx="6126480" cy="2514600"/>
+            <a:ext cx="6126480" cy="2743200"/>
           </a:xfrm>
           <a:prstGeom prst="roundRect">
             <a:avLst>
-              <a:gd name="adj" fmla="val 3636"/>
+              <a:gd name="adj" fmla="val 3333"/>
             </a:avLst>
           </a:prstGeom>
           <a:solidFill>
@@ -14443,7 +14436,7 @@
         <p:spPr>
           <a:xfrm>
             <a:off x="777240" y="1874520"/>
-            <a:ext cx="5669280" cy="1874520"/>
+            <a:ext cx="5669280" cy="2103120"/>
           </a:xfrm>
           <a:prstGeom prst="rect">
             <a:avLst/>
@@ -14590,6 +14583,26 @@
                 <a:ea typeface="Courier New" pitchFamily="34" charset="-122"/>
                 <a:cs typeface="Courier New" pitchFamily="34" charset="-120"/>
               </a:rPr>
+              <a:t>     --eligible eligible.txt \</a:t>
+            </a:r>
+            <a:endParaRPr lang="en-US" sz="1200" dirty="0"/>
+          </a:p>
+          <a:p>
+            <a:pPr marL="0" indent="0">
+              <a:lnSpc>
+                <a:spcPct val="115000"/>
+              </a:lnSpc>
+              <a:buNone/>
+            </a:pPr>
+            <a:r>
+              <a:rPr lang="en-US" sz="1200" dirty="0">
+                <a:solidFill>
+                  <a:srgbClr val="FFFFFF"/>
+                </a:solidFill>
+                <a:latin typeface="Courier New" pitchFamily="34" charset="0"/>
+                <a:ea typeface="Courier New" pitchFamily="34" charset="-122"/>
+                <a:cs typeface="Courier New" pitchFamily="34" charset="-120"/>
+              </a:rPr>
               <a:t>     --out reports/wbso_2026-09.xlsx</a:t>
             </a:r>
             <a:endParaRPr lang="en-US" sz="1200" dirty="0"/>
@@ -14604,7 +14617,7 @@
         </p:nvSpPr>
         <p:spPr>
           <a:xfrm>
-            <a:off x="548640" y="4069080"/>
+            <a:off x="548640" y="4297680"/>
             <a:ext cx="411480" cy="411480"/>
           </a:xfrm>
           <a:prstGeom prst="ellipse">
@@ -14644,7 +14657,7 @@
         </p:blipFill>
         <p:spPr>
           <a:xfrm>
-            <a:off x="647395" y="4167835"/>
+            <a:off x="647395" y="4396435"/>
             <a:ext cx="213970" cy="213970"/>
           </a:xfrm>
           <a:prstGeom prst="rect">
@@ -14660,7 +14673,7 @@
         </p:nvSpPr>
         <p:spPr>
           <a:xfrm>
-            <a:off x="1143000" y="4023360"/>
+            <a:off x="1143000" y="4251960"/>
             <a:ext cx="5532120" cy="548640"/>
           </a:xfrm>
           <a:prstGeom prst="rect">
@@ -14685,7 +14698,7 @@
                   <a:schemeClr val="tx1"/>
                 </a:solidFill>
               </a:rPr>
-              <a:t>Defaults: --project VALCM, --label wbso, --base https://skycell.atlassian.net. Run it once per month; earlier months can be backfilled any time.</a:t>
+              <a:t>Defaults: --project VALCM, --label wbso, --rvo-project 2601. Run it once per month; earlier months can be backfilled any time.</a:t>
             </a:r>
             <a:endParaRPr lang="en-US" sz="1150" dirty="0"/>
           </a:p>
@@ -14699,7 +14712,7 @@
         </p:nvSpPr>
         <p:spPr>
           <a:xfrm>
-            <a:off x="548640" y="4754880"/>
+            <a:off x="548640" y="4937760"/>
             <a:ext cx="411480" cy="411480"/>
           </a:xfrm>
           <a:prstGeom prst="ellipse">
@@ -14739,7 +14752,7 @@
         </p:blipFill>
         <p:spPr>
           <a:xfrm>
-            <a:off x="647395" y="4853635"/>
+            <a:off x="647395" y="5036515"/>
             <a:ext cx="213970" cy="213970"/>
           </a:xfrm>
           <a:prstGeom prst="rect">
@@ -14755,7 +14768,7 @@
         </p:nvSpPr>
         <p:spPr>
           <a:xfrm>
-            <a:off x="1143000" y="4709160"/>
+            <a:off x="1143000" y="4892040"/>
             <a:ext cx="5532120" cy="548640"/>
           </a:xfrm>
           <a:prstGeom prst="rect">
@@ -14794,7 +14807,7 @@
         </p:nvSpPr>
         <p:spPr>
           <a:xfrm>
-            <a:off x="548640" y="5440680"/>
+            <a:off x="548640" y="5577840"/>
             <a:ext cx="411480" cy="411480"/>
           </a:xfrm>
           <a:prstGeom prst="ellipse">
@@ -14834,7 +14847,7 @@
         </p:blipFill>
         <p:spPr>
           <a:xfrm>
-            <a:off x="647395" y="5539435"/>
+            <a:off x="647395" y="5676595"/>
             <a:ext cx="213970" cy="213970"/>
           </a:xfrm>
           <a:prstGeom prst="rect">
@@ -14850,7 +14863,7 @@
         </p:nvSpPr>
         <p:spPr>
           <a:xfrm>
-            <a:off x="1143000" y="5394960"/>
+            <a:off x="1143000" y="5532120"/>
             <a:ext cx="5532120" cy="548640"/>
           </a:xfrm>
           <a:prstGeom prst="rect">
@@ -14960,7 +14973,7 @@
         <p:spPr>
           <a:xfrm>
             <a:off x="7223760" y="1965960"/>
-            <a:ext cx="1325880" cy="292608"/>
+            <a:ext cx="1645920" cy="292608"/>
           </a:xfrm>
           <a:prstGeom prst="roundRect">
             <a:avLst>
@@ -14994,7 +15007,7 @@
         <p:spPr>
           <a:xfrm>
             <a:off x="7223760" y="1965960"/>
-            <a:ext cx="1325880" cy="292608"/>
+            <a:ext cx="1645920" cy="292608"/>
           </a:xfrm>
           <a:prstGeom prst="rect">
             <a:avLst/>
@@ -15069,7 +15082,7 @@
         <p:spPr>
           <a:xfrm>
             <a:off x="7223760" y="2971800"/>
-            <a:ext cx="1325880" cy="292608"/>
+            <a:ext cx="1645920" cy="292608"/>
           </a:xfrm>
           <a:prstGeom prst="roundRect">
             <a:avLst>
@@ -15103,7 +15116,7 @@
         <p:spPr>
           <a:xfrm>
             <a:off x="7223760" y="2971800"/>
-            <a:ext cx="1325880" cy="292608"/>
+            <a:ext cx="1645920" cy="292608"/>
           </a:xfrm>
           <a:prstGeom prst="rect">
             <a:avLst/>
@@ -15178,7 +15191,7 @@
         <p:spPr>
           <a:xfrm>
             <a:off x="7223760" y="3977640"/>
-            <a:ext cx="1325880" cy="292608"/>
+            <a:ext cx="1645920" cy="292608"/>
           </a:xfrm>
           <a:prstGeom prst="roundRect">
             <a:avLst>
@@ -15212,7 +15225,7 @@
         <p:spPr>
           <a:xfrm>
             <a:off x="7223760" y="3977640"/>
-            <a:ext cx="1325880" cy="292608"/>
+            <a:ext cx="1645920" cy="292608"/>
           </a:xfrm>
           <a:prstGeom prst="rect">
             <a:avLst/>
@@ -15233,7 +15246,7 @@
                   <a:schemeClr val="bg1"/>
                 </a:solidFill>
               </a:rPr>
-              <a:t>Summary</a:t>
+              <a:t>Summary and Daily</a:t>
             </a:r>
             <a:endParaRPr lang="en-US" sz="1000" dirty="0"/>
           </a:p>
@@ -15272,7 +15285,7 @@
                   <a:schemeClr val="tx1"/>
                 </a:solidFill>
               </a:rPr>
-              <a:t>Person × month. Remove people who are not on Validaide B.V. payroll before anything goes to SubVice.</a:t>
+              <a:t>Only names in eligible.txt are counted; everyone else sits in a NOT COUNTED block so totals reconcile. Daily is the per-person, per-project, per-day record RVO asks for.</a:t>
             </a:r>
             <a:endParaRPr lang="en-US" sz="1100" dirty="0"/>
           </a:p>
@@ -15287,7 +15300,7 @@
         <p:spPr>
           <a:xfrm>
             <a:off x="7223760" y="4983480"/>
-            <a:ext cx="1325880" cy="292608"/>
+            <a:ext cx="1645920" cy="292608"/>
           </a:xfrm>
           <a:prstGeom prst="roundRect">
             <a:avLst>
@@ -15321,7 +15334,7 @@
         <p:spPr>
           <a:xfrm>
             <a:off x="7223760" y="4983480"/>
-            <a:ext cx="1325880" cy="292608"/>
+            <a:ext cx="1645920" cy="292608"/>
           </a:xfrm>
           <a:prstGeom prst="rect">
             <a:avLst/>
@@ -15342,7 +15355,7 @@
                   <a:schemeClr val="bg1"/>
                 </a:solidFill>
               </a:rPr>
-              <a:t>Detail and Notes</a:t>
+              <a:t>Evidence and Notes</a:t>
             </a:r>
             <a:endParaRPr lang="en-US" sz="1000" dirty="0"/>
           </a:p>
@@ -15381,7 +15394,7 @@
                   <a:schemeClr val="tx1"/>
                 </a:solidFill>
               </a:rPr>
-              <a:t>The audit trail and the written methodology. They ship in every file; do not edit them.</a:t>
+              <a:t>Evidence lists every status change of the month with author and link; Notes carries the written methodology. Both ship in every file.</a:t>
             </a:r>
             <a:endParaRPr lang="en-US" sz="1100" dirty="0"/>
           </a:p>
@@ -15407,7 +15420,7 @@
           </a:prstGeom>
           <a:extLst>
             <a:ext uri="{C572A759-6A51-4108-AA02-DFA0A04FC94B}">
-              <ma14:wrappingTextBoxFlag xmlns:ma14="http://schemas.microsoft.com/office/mac/drawingml/2011/main" xmlns="" val="0"/>
+              <ma14:wrappingTextBoxFlag xmlns="" xmlns:ma14="http://schemas.microsoft.com/office/mac/drawingml/2011/main" val="0"/>
             </a:ext>
           </a:extLst>
         </p:spPr>

</xml_diff>